<commit_message>
Reword intro audience and add scroll-down instruction to step 4
Co-Authored-By: Claude Opus 5.5 <noreply@anthropic.com>
Claude-Session: https://claude.ai/code/session_01PKtiSCsUmxij3S1QgC1bpy
</commit_message>
<xml_diff>
--- a/Skill_Boost_Registration_Guide.pptx
+++ b/Skill_Boost_Registration_Guide.pptx
@@ -1349,7 +1349,7 @@
                 <a:ea typeface="Google Sans" pitchFamily="34" charset="-122"/>
                 <a:cs typeface="Google Sans" pitchFamily="34" charset="-120"/>
               </a:rPr>
-              <a:t>For everyone who missed the session: how to register for Skill Boost (now called Google Skills). Follow the screenshots to fill in both forms.</a:t>
+              <a:t>For anyone who missed the session: how to register for Skill Boost (now called Google Skills). Follow the screenshots to fill in both forms.</a:t>
             </a:r>
             <a:endParaRPr lang="en-US" sz="1400" dirty="0"/>
           </a:p>
@@ -3981,7 +3981,7 @@
                 <a:ea typeface="Google Sans" pitchFamily="34" charset="-122"/>
                 <a:cs typeface="Google Sans" pitchFamily="34" charset="-120"/>
               </a:rPr>
-              <a:t>In Settings, make your profile public so Google can verify your badges.</a:t>
+              <a:t>In Settings, scroll down to the Public visibility section so Google can verify your badges.</a:t>
             </a:r>
             <a:endParaRPr lang="en-US" sz="1400" dirty="0"/>
           </a:p>
@@ -4129,7 +4129,7 @@
                 <a:ea typeface="Google Sans" pitchFamily="34" charset="-122"/>
                 <a:cs typeface="Google Sans" pitchFamily="34" charset="-120"/>
               </a:rPr>
-              <a:t>Under Public visibility, tick the checkbox, marked with the first red box.</a:t>
+              <a:t>Scroll down to Public visibility, then tick the checkbox in the first red box.</a:t>
             </a:r>
             <a:endParaRPr lang="en-US" sz="1200" dirty="0"/>
           </a:p>

</xml_diff>

<commit_message>
Thinner red highlight boxes; fix name-field box overlapping labels
Co-Authored-By: Claude Opus 5.5 <noreply@anthropic.com>
Claude-Session: https://claude.ai/code/session_01PKtiSCsUmxij3S1QgC1bpy
</commit_message>
<xml_diff>
--- a/Skill_Boost_Registration_Guide.pptx
+++ b/Skill_Boost_Registration_Guide.pptx
@@ -2236,8 +2236,8 @@
         </p:nvSpPr>
         <p:spPr>
           <a:xfrm>
-            <a:off x="8536676" y="2792682"/>
-            <a:ext cx="2950831" cy="1130756"/>
+            <a:off x="8523094" y="2711186"/>
+            <a:ext cx="2977996" cy="1222438"/>
           </a:xfrm>
           <a:prstGeom prst="roundRect">
             <a:avLst>
@@ -2245,7 +2245,7 @@
             </a:avLst>
           </a:prstGeom>
           <a:noFill/>
-          <a:ln w="31750">
+          <a:ln w="19050">
             <a:solidFill>
               <a:srgbClr val="EA4335"/>
             </a:solidFill>
@@ -2267,8 +2267,8 @@
         </p:nvSpPr>
         <p:spPr>
           <a:xfrm>
-            <a:off x="10804979" y="4279983"/>
-            <a:ext cx="682528" cy="380314"/>
+            <a:off x="10811770" y="4286774"/>
+            <a:ext cx="668946" cy="366732"/>
           </a:xfrm>
           <a:prstGeom prst="roundRect">
             <a:avLst>
@@ -2276,7 +2276,7 @@
             </a:avLst>
           </a:prstGeom>
           <a:noFill/>
-          <a:ln w="31750">
+          <a:ln w="19050">
             <a:solidFill>
               <a:srgbClr val="EA4335"/>
             </a:solidFill>
@@ -2996,7 +2996,7 @@
             </a:avLst>
           </a:prstGeom>
           <a:noFill/>
-          <a:ln w="31750">
+          <a:ln w="19050">
             <a:solidFill>
               <a:srgbClr val="EA4335"/>
             </a:solidFill>
@@ -3024,7 +3024,7 @@
           <a:prstGeom prst="line">
             <a:avLst/>
           </a:prstGeom>
-          <a:ln w="38100">
+          <a:ln w="28575">
             <a:solidFill>
               <a:srgbClr val="EA4335"/>
             </a:solidFill>
@@ -3738,7 +3738,7 @@
             </a:avLst>
           </a:prstGeom>
           <a:noFill/>
-          <a:ln w="31750">
+          <a:ln w="19050">
             <a:solidFill>
               <a:srgbClr val="EA4335"/>
             </a:solidFill>
@@ -3766,7 +3766,7 @@
           <a:prstGeom prst="line">
             <a:avLst/>
           </a:prstGeom>
-          <a:ln w="38100">
+          <a:ln w="28575">
             <a:solidFill>
               <a:srgbClr val="EA4335"/>
             </a:solidFill>
@@ -4480,7 +4480,7 @@
             </a:avLst>
           </a:prstGeom>
           <a:noFill/>
-          <a:ln w="31750">
+          <a:ln w="19050">
             <a:solidFill>
               <a:srgbClr val="EA4335"/>
             </a:solidFill>
@@ -4511,7 +4511,7 @@
             </a:avLst>
           </a:prstGeom>
           <a:noFill/>
-          <a:ln w="31750">
+          <a:ln w="19050">
             <a:solidFill>
               <a:srgbClr val="EA4335"/>
             </a:solidFill>
@@ -5231,7 +5231,7 @@
             </a:avLst>
           </a:prstGeom>
           <a:noFill/>
-          <a:ln w="31750">
+          <a:ln w="19050">
             <a:solidFill>
               <a:srgbClr val="EA4335"/>
             </a:solidFill>
@@ -5974,7 +5974,7 @@
             </a:avLst>
           </a:prstGeom>
           <a:noFill/>
-          <a:ln w="31750">
+          <a:ln w="19050">
             <a:solidFill>
               <a:srgbClr val="EA4335"/>
             </a:solidFill>
@@ -6694,7 +6694,7 @@
             </a:avLst>
           </a:prstGeom>
           <a:noFill/>
-          <a:ln w="31750">
+          <a:ln w="19050">
             <a:solidFill>
               <a:srgbClr val="EA4335"/>
             </a:solidFill>
@@ -6725,7 +6725,7 @@
             </a:avLst>
           </a:prstGeom>
           <a:noFill/>
-          <a:ln w="31750">
+          <a:ln w="19050">
             <a:solidFill>
               <a:srgbClr val="EA4335"/>
             </a:solidFill>
@@ -7445,7 +7445,7 @@
             </a:avLst>
           </a:prstGeom>
           <a:noFill/>
-          <a:ln w="31750">
+          <a:ln w="19050">
             <a:solidFill>
               <a:srgbClr val="EA4335"/>
             </a:solidFill>
@@ -8165,7 +8165,7 @@
             </a:avLst>
           </a:prstGeom>
           <a:noFill/>
-          <a:ln w="31750">
+          <a:ln w="19050">
             <a:solidFill>
               <a:srgbClr val="EA4335"/>
             </a:solidFill>
@@ -8196,7 +8196,7 @@
             </a:avLst>
           </a:prstGeom>
           <a:noFill/>
-          <a:ln w="31750">
+          <a:ln w="19050">
             <a:solidFill>
               <a:srgbClr val="EA4335"/>
             </a:solidFill>
@@ -8227,7 +8227,7 @@
             </a:avLst>
           </a:prstGeom>
           <a:noFill/>
-          <a:ln w="31750">
+          <a:ln w="19050">
             <a:solidFill>
               <a:srgbClr val="EA4335"/>
             </a:solidFill>
@@ -8947,7 +8947,7 @@
             </a:avLst>
           </a:prstGeom>
           <a:noFill/>
-          <a:ln w="31750">
+          <a:ln w="19050">
             <a:solidFill>
               <a:srgbClr val="EA4335"/>
             </a:solidFill>
@@ -9667,7 +9667,7 @@
             </a:avLst>
           </a:prstGeom>
           <a:noFill/>
-          <a:ln w="31750">
+          <a:ln w="19050">
             <a:solidFill>
               <a:srgbClr val="EA4335"/>
             </a:solidFill>
@@ -9698,7 +9698,7 @@
             </a:avLst>
           </a:prstGeom>
           <a:noFill/>
-          <a:ln w="31750">
+          <a:ln w="19050">
             <a:solidFill>
               <a:srgbClr val="EA4335"/>
             </a:solidFill>
@@ -9729,7 +9729,7 @@
             </a:avLst>
           </a:prstGeom>
           <a:noFill/>
-          <a:ln w="31750">
+          <a:ln w="19050">
             <a:solidFill>
               <a:srgbClr val="EA4335"/>
             </a:solidFill>
@@ -10449,7 +10449,7 @@
             </a:avLst>
           </a:prstGeom>
           <a:noFill/>
-          <a:ln w="31750">
+          <a:ln w="19050">
             <a:solidFill>
               <a:srgbClr val="EA4335"/>
             </a:solidFill>
@@ -10480,7 +10480,7 @@
             </a:avLst>
           </a:prstGeom>
           <a:noFill/>
-          <a:ln w="31750">
+          <a:ln w="19050">
             <a:solidFill>
               <a:srgbClr val="EA4335"/>
             </a:solidFill>
@@ -10511,7 +10511,7 @@
             </a:avLst>
           </a:prstGeom>
           <a:noFill/>
-          <a:ln w="31750">
+          <a:ln w="19050">
             <a:solidFill>
               <a:srgbClr val="EA4335"/>
             </a:solidFill>
@@ -11261,7 +11261,7 @@
             </a:avLst>
           </a:prstGeom>
           <a:noFill/>
-          <a:ln w="31750">
+          <a:ln w="19050">
             <a:solidFill>
               <a:srgbClr val="EA4335"/>
             </a:solidFill>
@@ -11292,7 +11292,7 @@
             </a:avLst>
           </a:prstGeom>
           <a:noFill/>
-          <a:ln w="31750">
+          <a:ln w="19050">
             <a:solidFill>
               <a:srgbClr val="EA4335"/>
             </a:solidFill>
@@ -11809,7 +11809,7 @@
                 <a:ea typeface="Google Sans" pitchFamily="34" charset="-122"/>
                 <a:cs typeface="Google Sans" pitchFamily="34" charset="-120"/>
               </a:rPr>
-              <a:t>Tick the second red box: you agree to finish the Learning Pathway on Google Skills on time.</a:t>
+              <a:t>Tick the second red box: you agree to finish the Learning Pathway on time.</a:t>
             </a:r>
             <a:endParaRPr lang="en-US" sz="1200" dirty="0"/>
           </a:p>
@@ -12012,7 +12012,7 @@
             </a:avLst>
           </a:prstGeom>
           <a:noFill/>
-          <a:ln w="31750">
+          <a:ln w="19050">
             <a:solidFill>
               <a:srgbClr val="EA4335"/>
             </a:solidFill>
@@ -12043,7 +12043,7 @@
             </a:avLst>
           </a:prstGeom>
           <a:noFill/>
-          <a:ln w="31750">
+          <a:ln w="19050">
             <a:solidFill>
               <a:srgbClr val="EA4335"/>
             </a:solidFill>
@@ -12763,7 +12763,7 @@
             </a:avLst>
           </a:prstGeom>
           <a:noFill/>
-          <a:ln w="31750">
+          <a:ln w="19050">
             <a:solidFill>
               <a:srgbClr val="EA4335"/>
             </a:solidFill>
@@ -12794,7 +12794,7 @@
             </a:avLst>
           </a:prstGeom>
           <a:noFill/>
-          <a:ln w="31750">
+          <a:ln w="19050">
             <a:solidFill>
               <a:srgbClr val="EA4335"/>
             </a:solidFill>
@@ -12825,7 +12825,7 @@
             </a:avLst>
           </a:prstGeom>
           <a:noFill/>
-          <a:ln w="31750">
+          <a:ln w="19050">
             <a:solidFill>
               <a:srgbClr val="EA4335"/>
             </a:solidFill>
@@ -14140,7 +14140,7 @@
             </a:avLst>
           </a:prstGeom>
           <a:noFill/>
-          <a:ln w="31750">
+          <a:ln w="19050">
             <a:solidFill>
               <a:srgbClr val="EA4335"/>
             </a:solidFill>
@@ -14171,7 +14171,7 @@
             </a:avLst>
           </a:prstGeom>
           <a:noFill/>
-          <a:ln w="31750">
+          <a:ln w="19050">
             <a:solidFill>
               <a:srgbClr val="EA4335"/>
             </a:solidFill>
@@ -14914,7 +14914,7 @@
             </a:avLst>
           </a:prstGeom>
           <a:noFill/>
-          <a:ln w="31750">
+          <a:ln w="19050">
             <a:solidFill>
               <a:srgbClr val="EA4335"/>
             </a:solidFill>
@@ -14945,7 +14945,7 @@
             </a:avLst>
           </a:prstGeom>
           <a:noFill/>
-          <a:ln w="31750">
+          <a:ln w="19050">
             <a:solidFill>
               <a:srgbClr val="EA4335"/>
             </a:solidFill>
@@ -15665,7 +15665,7 @@
             </a:avLst>
           </a:prstGeom>
           <a:noFill/>
-          <a:ln w="31750">
+          <a:ln w="19050">
             <a:solidFill>
               <a:srgbClr val="EA4335"/>
             </a:solidFill>
@@ -15696,7 +15696,7 @@
             </a:avLst>
           </a:prstGeom>
           <a:noFill/>
-          <a:ln w="31750">
+          <a:ln w="19050">
             <a:solidFill>
               <a:srgbClr val="EA4335"/>
             </a:solidFill>

</xml_diff>

<commit_message>
Use square-cornered rectangles for all red highlight boxes
Co-Authored-By: Claude Opus 5.5 <noreply@anthropic.com>
Claude-Session: https://claude.ai/code/session_01PKtiSCsUmxij3S1QgC1bpy
</commit_message>
<xml_diff>
--- a/Skill_Boost_Registration_Guide.pptx
+++ b/Skill_Boost_Registration_Guide.pptx
@@ -2239,10 +2239,8 @@
             <a:off x="8523094" y="2711186"/>
             <a:ext cx="2977996" cy="1222438"/>
           </a:xfrm>
-          <a:prstGeom prst="roundRect">
-            <a:avLst>
-              <a:gd name="adj" fmla="val 15000"/>
-            </a:avLst>
+          <a:prstGeom prst="rect">
+            <a:avLst/>
           </a:prstGeom>
           <a:noFill/>
           <a:ln w="19050">
@@ -2270,10 +2268,8 @@
             <a:off x="10811770" y="4286774"/>
             <a:ext cx="668946" cy="366732"/>
           </a:xfrm>
-          <a:prstGeom prst="roundRect">
-            <a:avLst>
-              <a:gd name="adj" fmla="val 15000"/>
-            </a:avLst>
+          <a:prstGeom prst="rect">
+            <a:avLst/>
           </a:prstGeom>
           <a:noFill/>
           <a:ln w="19050">
@@ -2990,10 +2986,8 @@
             <a:off x="11215854" y="2035450"/>
             <a:ext cx="342962" cy="237696"/>
           </a:xfrm>
-          <a:prstGeom prst="roundRect">
-            <a:avLst>
-              <a:gd name="adj" fmla="val 15000"/>
-            </a:avLst>
+          <a:prstGeom prst="rect">
+            <a:avLst/>
           </a:prstGeom>
           <a:noFill/>
           <a:ln w="19050">
@@ -3732,10 +3726,8 @@
             <a:off x="11324515" y="2025263"/>
             <a:ext cx="234301" cy="234301"/>
           </a:xfrm>
-          <a:prstGeom prst="roundRect">
-            <a:avLst>
-              <a:gd name="adj" fmla="val 50000"/>
-            </a:avLst>
+          <a:prstGeom prst="rect">
+            <a:avLst/>
           </a:prstGeom>
           <a:noFill/>
           <a:ln w="19050">
@@ -4474,10 +4466,8 @@
             <a:off x="6287516" y="2832608"/>
             <a:ext cx="1068832" cy="211328"/>
           </a:xfrm>
-          <a:prstGeom prst="roundRect">
-            <a:avLst>
-              <a:gd name="adj" fmla="val 15000"/>
-            </a:avLst>
+          <a:prstGeom prst="rect">
+            <a:avLst/>
           </a:prstGeom>
           <a:noFill/>
           <a:ln w="19050">
@@ -4505,10 +4495,8 @@
             <a:off x="6287516" y="5376672"/>
             <a:ext cx="865632" cy="345440"/>
           </a:xfrm>
-          <a:prstGeom prst="roundRect">
-            <a:avLst>
-              <a:gd name="adj" fmla="val 15000"/>
-            </a:avLst>
+          <a:prstGeom prst="rect">
+            <a:avLst/>
           </a:prstGeom>
           <a:noFill/>
           <a:ln w="19050">
@@ -5225,10 +5213,8 @@
             <a:off x="6295644" y="3503168"/>
             <a:ext cx="3364992" cy="373888"/>
           </a:xfrm>
-          <a:prstGeom prst="roundRect">
-            <a:avLst>
-              <a:gd name="adj" fmla="val 15000"/>
-            </a:avLst>
+          <a:prstGeom prst="rect">
+            <a:avLst/>
           </a:prstGeom>
           <a:noFill/>
           <a:ln w="19050">
@@ -5968,10 +5954,8 @@
             <a:off x="6091716" y="3499564"/>
             <a:ext cx="4520587" cy="952701"/>
           </a:xfrm>
-          <a:prstGeom prst="roundRect">
-            <a:avLst>
-              <a:gd name="adj" fmla="val 15000"/>
-            </a:avLst>
+          <a:prstGeom prst="rect">
+            <a:avLst/>
           </a:prstGeom>
           <a:noFill/>
           <a:ln w="19050">
@@ -6688,10 +6672,8 @@
             <a:off x="6078220" y="4836973"/>
             <a:ext cx="2338019" cy="317398"/>
           </a:xfrm>
-          <a:prstGeom prst="roundRect">
-            <a:avLst>
-              <a:gd name="adj" fmla="val 15000"/>
-            </a:avLst>
+          <a:prstGeom prst="rect">
+            <a:avLst/>
           </a:prstGeom>
           <a:noFill/>
           <a:ln w="19050">
@@ -6719,10 +6701,8 @@
             <a:off x="5890463" y="5431536"/>
             <a:ext cx="688442" cy="348691"/>
           </a:xfrm>
-          <a:prstGeom prst="roundRect">
-            <a:avLst>
-              <a:gd name="adj" fmla="val 15000"/>
-            </a:avLst>
+          <a:prstGeom prst="rect">
+            <a:avLst/>
           </a:prstGeom>
           <a:noFill/>
           <a:ln w="19050">
@@ -7439,10 +7419,8 @@
             <a:off x="6346444" y="4738624"/>
             <a:ext cx="1332179" cy="326339"/>
           </a:xfrm>
-          <a:prstGeom prst="roundRect">
-            <a:avLst>
-              <a:gd name="adj" fmla="val 15000"/>
-            </a:avLst>
+          <a:prstGeom prst="rect">
+            <a:avLst/>
           </a:prstGeom>
           <a:noFill/>
           <a:ln w="19050">
@@ -8159,10 +8137,8 @@
             <a:off x="6051162" y="2594008"/>
             <a:ext cx="2371665" cy="307046"/>
           </a:xfrm>
-          <a:prstGeom prst="roundRect">
-            <a:avLst>
-              <a:gd name="adj" fmla="val 15000"/>
-            </a:avLst>
+          <a:prstGeom prst="rect">
+            <a:avLst/>
           </a:prstGeom>
           <a:noFill/>
           <a:ln w="19050">
@@ -8190,10 +8166,8 @@
             <a:off x="6051162" y="3711020"/>
             <a:ext cx="1932272" cy="460569"/>
           </a:xfrm>
-          <a:prstGeom prst="roundRect">
-            <a:avLst>
-              <a:gd name="adj" fmla="val 15000"/>
-            </a:avLst>
+          <a:prstGeom prst="rect">
+            <a:avLst/>
           </a:prstGeom>
           <a:noFill/>
           <a:ln w="19050">
@@ -8221,10 +8195,8 @@
             <a:off x="6051162" y="4965673"/>
             <a:ext cx="2218142" cy="460569"/>
           </a:xfrm>
-          <a:prstGeom prst="roundRect">
-            <a:avLst>
-              <a:gd name="adj" fmla="val 15000"/>
-            </a:avLst>
+          <a:prstGeom prst="rect">
+            <a:avLst/>
           </a:prstGeom>
           <a:noFill/>
           <a:ln w="19050">
@@ -8941,10 +8913,8 @@
             <a:off x="5824997" y="3676525"/>
             <a:ext cx="2194568" cy="488975"/>
           </a:xfrm>
-          <a:prstGeom prst="roundRect">
-            <a:avLst>
-              <a:gd name="adj" fmla="val 15000"/>
-            </a:avLst>
+          <a:prstGeom prst="rect">
+            <a:avLst/>
           </a:prstGeom>
           <a:noFill/>
           <a:ln w="19050">
@@ -9661,10 +9631,8 @@
             <a:off x="5955437" y="3169085"/>
             <a:ext cx="2469131" cy="308641"/>
           </a:xfrm>
-          <a:prstGeom prst="roundRect">
-            <a:avLst>
-              <a:gd name="adj" fmla="val 15000"/>
-            </a:avLst>
+          <a:prstGeom prst="rect">
+            <a:avLst/>
           </a:prstGeom>
           <a:noFill/>
           <a:ln w="19050">
@@ -9692,10 +9660,8 @@
             <a:off x="5955437" y="4530414"/>
             <a:ext cx="551145" cy="259038"/>
           </a:xfrm>
-          <a:prstGeom prst="roundRect">
-            <a:avLst>
-              <a:gd name="adj" fmla="val 15000"/>
-            </a:avLst>
+          <a:prstGeom prst="rect">
+            <a:avLst/>
           </a:prstGeom>
           <a:noFill/>
           <a:ln w="19050">
@@ -9723,10 +9689,8 @@
             <a:off x="6528628" y="5401223"/>
             <a:ext cx="738535" cy="374779"/>
           </a:xfrm>
-          <a:prstGeom prst="roundRect">
-            <a:avLst>
-              <a:gd name="adj" fmla="val 15000"/>
-            </a:avLst>
+          <a:prstGeom prst="rect">
+            <a:avLst/>
           </a:prstGeom>
           <a:noFill/>
           <a:ln w="19050">
@@ -10443,10 +10407,8 @@
             <a:off x="5819176" y="2826639"/>
             <a:ext cx="745105" cy="279415"/>
           </a:xfrm>
-          <a:prstGeom prst="roundRect">
-            <a:avLst>
-              <a:gd name="adj" fmla="val 15000"/>
-            </a:avLst>
+          <a:prstGeom prst="rect">
+            <a:avLst/>
           </a:prstGeom>
           <a:noFill/>
           <a:ln w="19050">
@@ -10474,10 +10436,8 @@
             <a:off x="5819176" y="4689402"/>
             <a:ext cx="2607869" cy="291057"/>
           </a:xfrm>
-          <a:prstGeom prst="roundRect">
-            <a:avLst>
-              <a:gd name="adj" fmla="val 15000"/>
-            </a:avLst>
+          <a:prstGeom prst="rect">
+            <a:avLst/>
           </a:prstGeom>
           <a:noFill/>
           <a:ln w="19050">
@@ -10505,10 +10465,8 @@
             <a:off x="6424574" y="5265695"/>
             <a:ext cx="780032" cy="401658"/>
           </a:xfrm>
-          <a:prstGeom prst="roundRect">
-            <a:avLst>
-              <a:gd name="adj" fmla="val 15000"/>
-            </a:avLst>
+          <a:prstGeom prst="rect">
+            <a:avLst/>
           </a:prstGeom>
           <a:noFill/>
           <a:ln w="19050">
@@ -11255,10 +11213,8 @@
             <a:off x="5568696" y="2594610"/>
             <a:ext cx="5568696" cy="521208"/>
           </a:xfrm>
-          <a:prstGeom prst="roundRect">
-            <a:avLst>
-              <a:gd name="adj" fmla="val 15000"/>
-            </a:avLst>
+          <a:prstGeom prst="rect">
+            <a:avLst/>
           </a:prstGeom>
           <a:noFill/>
           <a:ln w="19050">
@@ -11286,10 +11242,8 @@
             <a:off x="5688338" y="5711107"/>
             <a:ext cx="2726361" cy="250962"/>
           </a:xfrm>
-          <a:prstGeom prst="roundRect">
-            <a:avLst>
-              <a:gd name="adj" fmla="val 15000"/>
-            </a:avLst>
+          <a:prstGeom prst="rect">
+            <a:avLst/>
           </a:prstGeom>
           <a:noFill/>
           <a:ln w="19050">
@@ -12006,10 +11960,8 @@
             <a:off x="6040379" y="3129338"/>
             <a:ext cx="1117658" cy="267772"/>
           </a:xfrm>
-          <a:prstGeom prst="roundRect">
-            <a:avLst>
-              <a:gd name="adj" fmla="val 15000"/>
-            </a:avLst>
+          <a:prstGeom prst="rect">
+            <a:avLst/>
           </a:prstGeom>
           <a:noFill/>
           <a:ln w="19050">
@@ -12037,10 +11989,8 @@
             <a:off x="6040379" y="4689402"/>
             <a:ext cx="954666" cy="279415"/>
           </a:xfrm>
-          <a:prstGeom prst="roundRect">
-            <a:avLst>
-              <a:gd name="adj" fmla="val 15000"/>
-            </a:avLst>
+          <a:prstGeom prst="rect">
+            <a:avLst/>
           </a:prstGeom>
           <a:noFill/>
           <a:ln w="19050">
@@ -12757,10 +12707,8 @@
             <a:off x="6346444" y="2682240"/>
             <a:ext cx="4269232" cy="307340"/>
           </a:xfrm>
-          <a:prstGeom prst="roundRect">
-            <a:avLst>
-              <a:gd name="adj" fmla="val 15000"/>
-            </a:avLst>
+          <a:prstGeom prst="rect">
+            <a:avLst/>
           </a:prstGeom>
           <a:noFill/>
           <a:ln w="19050">
@@ -12788,10 +12736,8 @@
             <a:off x="6346444" y="3017520"/>
             <a:ext cx="4269232" cy="648208"/>
           </a:xfrm>
-          <a:prstGeom prst="roundRect">
-            <a:avLst>
-              <a:gd name="adj" fmla="val 15000"/>
-            </a:avLst>
+          <a:prstGeom prst="rect">
+            <a:avLst/>
           </a:prstGeom>
           <a:noFill/>
           <a:ln w="19050">
@@ -12819,10 +12765,8 @@
             <a:off x="6698488" y="5588000"/>
             <a:ext cx="754380" cy="312928"/>
           </a:xfrm>
-          <a:prstGeom prst="roundRect">
-            <a:avLst>
-              <a:gd name="adj" fmla="val 15000"/>
-            </a:avLst>
+          <a:prstGeom prst="rect">
+            <a:avLst/>
           </a:prstGeom>
           <a:noFill/>
           <a:ln w="19050">
@@ -14134,10 +14078,8 @@
             <a:off x="5632212" y="2350055"/>
             <a:ext cx="5133395" cy="367261"/>
           </a:xfrm>
-          <a:prstGeom prst="roundRect">
-            <a:avLst>
-              <a:gd name="adj" fmla="val 15000"/>
-            </a:avLst>
+          <a:prstGeom prst="rect">
+            <a:avLst/>
           </a:prstGeom>
           <a:noFill/>
           <a:ln w="19050">
@@ -14165,10 +14107,8 @@
             <a:off x="5632212" y="2775087"/>
             <a:ext cx="2232449" cy="173314"/>
           </a:xfrm>
-          <a:prstGeom prst="roundRect">
-            <a:avLst>
-              <a:gd name="adj" fmla="val 15000"/>
-            </a:avLst>
+          <a:prstGeom prst="rect">
+            <a:avLst/>
           </a:prstGeom>
           <a:noFill/>
           <a:ln w="19050">
@@ -14908,10 +14848,8 @@
             <a:off x="6223955" y="4500799"/>
             <a:ext cx="4130650" cy="386243"/>
           </a:xfrm>
-          <a:prstGeom prst="roundRect">
-            <a:avLst>
-              <a:gd name="adj" fmla="val 15000"/>
-            </a:avLst>
+          <a:prstGeom prst="rect">
+            <a:avLst/>
           </a:prstGeom>
           <a:noFill/>
           <a:ln w="19050">
@@ -14939,10 +14877,8 @@
             <a:off x="6223955" y="5680984"/>
             <a:ext cx="2199437" cy="278953"/>
           </a:xfrm>
-          <a:prstGeom prst="roundRect">
-            <a:avLst>
-              <a:gd name="adj" fmla="val 15000"/>
-            </a:avLst>
+          <a:prstGeom prst="rect">
+            <a:avLst/>
           </a:prstGeom>
           <a:noFill/>
           <a:ln w="19050">
@@ -15659,10 +15595,8 @@
             <a:off x="5987989" y="4555516"/>
             <a:ext cx="2235316" cy="250309"/>
           </a:xfrm>
-          <a:prstGeom prst="roundRect">
-            <a:avLst>
-              <a:gd name="adj" fmla="val 15000"/>
-            </a:avLst>
+          <a:prstGeom prst="rect">
+            <a:avLst/>
           </a:prstGeom>
           <a:noFill/>
           <a:ln w="19050">
@@ -15690,10 +15624,8 @@
             <a:off x="6605030" y="5015386"/>
             <a:ext cx="832422" cy="372553"/>
           </a:xfrm>
-          <a:prstGeom prst="roundRect">
-            <a:avLst>
-              <a:gd name="adj" fmla="val 15000"/>
-            </a:avLst>
+          <a:prstGeom prst="rect">
+            <a:avLst/>
           </a:prstGeom>
           <a:noFill/>
           <a:ln w="19050">

</xml_diff>

<commit_message>
Add clickable links for accounts.google.com and skills.google
Co-Authored-By: Claude Opus 5.5 <noreply@anthropic.com>
Claude-Session: https://claude.ai/code/session_01PKtiSCsUmxij3S1QgC1bpy
</commit_message>
<xml_diff>
--- a/Skill_Boost_Registration_Guide.pptx
+++ b/Skill_Boost_Registration_Guide.pptx
@@ -1894,7 +1894,30 @@
                 <a:ea typeface="Google Sans" pitchFamily="34" charset="-122"/>
                 <a:cs typeface="Google Sans" pitchFamily="34" charset="-120"/>
               </a:rPr>
-              <a:t>Go to accounts.google.com and choose Create account, then For my personal use.</a:t>
+              <a:t xml:space="preserve">Go to </a:t>
+            </a:r>
+            <a:r>
+              <a:rPr u="sng" lang="en-US" sz="1200" dirty="0">
+                <a:solidFill>
+                  <a:srgbClr val="1A73E8"/>
+                </a:solidFill>
+                <a:latin typeface="Google Sans" pitchFamily="34" charset="0"/>
+                <a:ea typeface="Google Sans" pitchFamily="34" charset="-122"/>
+                <a:cs typeface="Google Sans" pitchFamily="34" charset="-120"/>
+                <a:hlinkClick r:id="rId61"/>
+              </a:rPr>
+              <a:t>accounts.google.com</a:t>
+            </a:r>
+            <a:r>
+              <a:rPr lang="en-US" sz="1200" dirty="0">
+                <a:solidFill>
+                  <a:srgbClr val="3C4043"/>
+                </a:solidFill>
+                <a:latin typeface="Google Sans" pitchFamily="34" charset="0"/>
+                <a:ea typeface="Google Sans" pitchFamily="34" charset="-122"/>
+                <a:cs typeface="Google Sans" pitchFamily="34" charset="-120"/>
+              </a:rPr>
+              <a:t xml:space="preserve"> and choose Create account, then For my personal use.</a:t>
             </a:r>
             <a:endParaRPr lang="en-US" sz="1200" dirty="0"/>
           </a:p>
@@ -2641,7 +2664,30 @@
                 <a:ea typeface="Google Sans" pitchFamily="34" charset="-122"/>
                 <a:cs typeface="Google Sans" pitchFamily="34" charset="-120"/>
               </a:rPr>
-              <a:t>Open skills.google (Google Skills, formerly Cloud Skills Boost) in your browser.</a:t>
+              <a:t xml:space="preserve">Open </a:t>
+            </a:r>
+            <a:r>
+              <a:rPr u="sng" lang="en-US" sz="1200" dirty="0">
+                <a:solidFill>
+                  <a:srgbClr val="1A73E8"/>
+                </a:solidFill>
+                <a:latin typeface="Google Sans" pitchFamily="34" charset="0"/>
+                <a:ea typeface="Google Sans" pitchFamily="34" charset="-122"/>
+                <a:cs typeface="Google Sans" pitchFamily="34" charset="-120"/>
+                <a:hlinkClick r:id="rId61"/>
+              </a:rPr>
+              <a:t>skills.google</a:t>
+            </a:r>
+            <a:r>
+              <a:rPr lang="en-US" sz="1200" dirty="0">
+                <a:solidFill>
+                  <a:srgbClr val="3C4043"/>
+                </a:solidFill>
+                <a:latin typeface="Google Sans" pitchFamily="34" charset="0"/>
+                <a:ea typeface="Google Sans" pitchFamily="34" charset="-122"/>
+                <a:cs typeface="Google Sans" pitchFamily="34" charset="-120"/>
+              </a:rPr>
+              <a:t xml:space="preserve"> (Google Skills, formerly Cloud Skills Boost) in your browser.</a:t>
             </a:r>
             <a:endParaRPr lang="en-US" sz="1200" dirty="0"/>
           </a:p>

</xml_diff>

<commit_message>
Add arrow and 'Mark this box' label to Make profile public on step 4
Co-Authored-By: Claude Opus 5.5 <noreply@anthropic.com>
Claude-Session: https://claude.ai/code/session_01PKtiSCsUmxij3S1QgC1bpy
</commit_message>
<xml_diff>
--- a/Skill_Boost_Registration_Guide.pptx
+++ b/Skill_Boost_Registration_Guide.pptx
@@ -4556,6 +4556,59 @@
           <a:lstStyle/>
           <a:p>
             <a:endParaRPr lang="en-US"/>
+          </a:p>
+        </p:txBody>
+      </p:sp>
+      <p:cxnSp>
+        <p:nvCxnSpPr>
+          <p:cNvPr id="110" name="Arrow 1"/>
+          <p:cNvCxnSpPr/>
+          <p:nvPr/>
+        </p:nvCxnSpPr>
+        <p:spPr>
+          <a:xfrm>
+            <a:off x="7380732" y="2934208"/>
+            <a:ext cx="731520" cy="0"/>
+          </a:xfrm>
+          <a:prstGeom prst="line">
+            <a:avLst/>
+          </a:prstGeom>
+          <a:ln w="28575">
+            <a:solidFill>
+              <a:srgbClr val="EA4335"/>
+            </a:solidFill>
+            <a:headEnd type="triangle" w="med" len="med"/>
+          </a:ln>
+        </p:spPr>
+      </p:cxnSp>
+      <p:sp>
+        <p:nvSpPr>
+          <p:cNvPr id="111" name="Mark this box label"/>
+          <p:cNvSpPr txBox="1"/>
+          <p:nvPr/>
+        </p:nvSpPr>
+        <p:spPr>
+          <a:xfrm>
+            <a:off x="8185404" y="2778760"/>
+            <a:ext cx="1463040" cy="310896"/>
+          </a:xfrm>
+          <a:prstGeom prst="rect">
+            <a:avLst/>
+          </a:prstGeom>
+          <a:noFill/>
+        </p:spPr>
+        <p:txBody>
+          <a:bodyPr wrap="none" lIns="0" tIns="0" rIns="0" bIns="0" anchor="ctr"/>
+          <a:lstStyle/>
+          <a:p>
+            <a:r>
+              <a:rPr lang="en-US" sz="1400" b="1" dirty="0">
+                <a:solidFill>
+                  <a:srgbClr val="EA4335"/>
+                </a:solidFill>
+              </a:rPr>
+              <a:t>Mark this box</a:t>
+            </a:r>
           </a:p>
         </p:txBody>
       </p:sp>

</xml_diff>

<commit_message>
Add 'Important' arrows to organiser option and referral code
Co-Authored-By: Claude Opus 5.5 <noreply@anthropic.com>
Claude-Session: https://claude.ai/code/session_01PKtiSCsUmxij3S1QgC1bpy
</commit_message>
<xml_diff>
--- a/Skill_Boost_Registration_Guide.pptx
+++ b/Skill_Boost_Registration_Guide.pptx
@@ -9030,6 +9030,59 @@
           </a:p>
         </p:txBody>
       </p:sp>
+      <p:cxnSp>
+        <p:nvCxnSpPr>
+          <p:cNvPr id="110" name="Arrow 1"/>
+          <p:cNvCxnSpPr/>
+          <p:nvPr/>
+        </p:nvCxnSpPr>
+        <p:spPr>
+          <a:xfrm>
+            <a:off x="8054492" y="3921013"/>
+            <a:ext cx="731520" cy="0"/>
+          </a:xfrm>
+          <a:prstGeom prst="line">
+            <a:avLst/>
+          </a:prstGeom>
+          <a:ln w="28575">
+            <a:solidFill>
+              <a:srgbClr val="EA4335"/>
+            </a:solidFill>
+            <a:headEnd type="triangle" w="med" len="med"/>
+          </a:ln>
+        </p:spPr>
+      </p:cxnSp>
+      <p:sp>
+        <p:nvSpPr>
+          <p:cNvPr id="111" name="Important label"/>
+          <p:cNvSpPr txBox="1"/>
+          <p:nvPr/>
+        </p:nvSpPr>
+        <p:spPr>
+          <a:xfrm>
+            <a:off x="8859164" y="3765565"/>
+            <a:ext cx="1188720" cy="310896"/>
+          </a:xfrm>
+          <a:prstGeom prst="rect">
+            <a:avLst/>
+          </a:prstGeom>
+          <a:noFill/>
+        </p:spPr>
+        <p:txBody>
+          <a:bodyPr wrap="none" lIns="0" tIns="0" rIns="0" bIns="0" anchor="ctr"/>
+          <a:lstStyle/>
+          <a:p>
+            <a:r>
+              <a:rPr lang="en-US" sz="1400" b="1" dirty="0">
+                <a:solidFill>
+                  <a:srgbClr val="EA4335"/>
+                </a:solidFill>
+              </a:rPr>
+              <a:t>Important</a:t>
+            </a:r>
+          </a:p>
+        </p:txBody>
+      </p:sp>
     </p:spTree>
   </p:cSld>
   <p:clrMapOvr>
@@ -9533,7 +9586,7 @@
                 <a:ea typeface="Google Sans" pitchFamily="34" charset="-122"/>
                 <a:cs typeface="Google Sans" pitchFamily="34" charset="-120"/>
               </a:rPr>
-              <a:t>Enter it exactly as given, in capital letters with the hyphen. Without it you cannot be credited to APSIT.</a:t>
+              <a:t>Type it exactly, in capitals with the hyphen, or you will not be credited to APSIT.</a:t>
             </a:r>
             <a:endParaRPr lang="en-US" sz="1200" dirty="0"/>
           </a:p>
@@ -9803,6 +9856,59 @@
           <a:lstStyle/>
           <a:p>
             <a:endParaRPr lang="en-US"/>
+          </a:p>
+        </p:txBody>
+      </p:sp>
+      <p:cxnSp>
+        <p:nvCxnSpPr>
+          <p:cNvPr id="110" name="Arrow 1"/>
+          <p:cNvCxnSpPr/>
+          <p:nvPr/>
+        </p:nvCxnSpPr>
+        <p:spPr>
+          <a:xfrm>
+            <a:off x="8457636" y="3323406"/>
+            <a:ext cx="731520" cy="0"/>
+          </a:xfrm>
+          <a:prstGeom prst="line">
+            <a:avLst/>
+          </a:prstGeom>
+          <a:ln w="28575">
+            <a:solidFill>
+              <a:srgbClr val="EA4335"/>
+            </a:solidFill>
+            <a:headEnd type="triangle" w="med" len="med"/>
+          </a:ln>
+        </p:spPr>
+      </p:cxnSp>
+      <p:sp>
+        <p:nvSpPr>
+          <p:cNvPr id="111" name="Important label"/>
+          <p:cNvSpPr txBox="1"/>
+          <p:nvPr/>
+        </p:nvSpPr>
+        <p:spPr>
+          <a:xfrm>
+            <a:off x="9262308" y="3167958"/>
+            <a:ext cx="1188720" cy="310896"/>
+          </a:xfrm>
+          <a:prstGeom prst="rect">
+            <a:avLst/>
+          </a:prstGeom>
+          <a:noFill/>
+        </p:spPr>
+        <p:txBody>
+          <a:bodyPr wrap="none" lIns="0" tIns="0" rIns="0" bIns="0" anchor="ctr"/>
+          <a:lstStyle/>
+          <a:p>
+            <a:r>
+              <a:rPr lang="en-US" sz="1400" b="1" dirty="0">
+                <a:solidFill>
+                  <a:srgbClr val="EA4335"/>
+                </a:solidFill>
+              </a:rPr>
+              <a:t>Important</a:t>
+            </a:r>
           </a:p>
         </p:txBody>
       </p:sp>

</xml_diff>

<commit_message>
Improve final contacts slide, tidy form-link wording, add PDF export
Co-Authored-By: Claude Opus 5.5 <noreply@anthropic.com>
Claude-Session: https://claude.ai/code/session_01PKtiSCsUmxij3S1QgC1bpy
</commit_message>
<xml_diff>
--- a/Skill_Boost_Registration_Guide.pptx
+++ b/Skill_Boost_Registration_Guide.pptx
@@ -5685,7 +5685,7 @@
                 <a:ea typeface="Google Sans" pitchFamily="34" charset="-122"/>
                 <a:cs typeface="Google Sans" pitchFamily="34" charset="-120"/>
               </a:rPr>
-              <a:t>Click </a:t>
+              <a:t>Open </a:t>
             </a:r>
             <a:r>
               <a:rPr u="sng" lang="en-US" sz="1200" dirty="0">
@@ -5708,7 +5708,7 @@
                 <a:ea typeface="Google Sans" pitchFamily="34" charset="-122"/>
                 <a:cs typeface="Google Sans" pitchFamily="34" charset="-120"/>
               </a:rPr>
-              <a:t> to open it.</a:t>
+              <a:t> in your browser.</a:t>
             </a:r>
             <a:endParaRPr lang="en-US" sz="1200" dirty="0"/>
           </a:p>
@@ -14685,7 +14685,7 @@
                 <a:ea typeface="Google Sans" pitchFamily="34" charset="-122"/>
                 <a:cs typeface="Google Sans" pitchFamily="34" charset="-120"/>
               </a:rPr>
-              <a:t>Click </a:t>
+              <a:t>Open </a:t>
             </a:r>
             <a:r>
               <a:rPr u="sng" lang="en-US" sz="1200" dirty="0">
@@ -14708,7 +14708,7 @@
                 <a:ea typeface="Google Sans" pitchFamily="34" charset="-122"/>
                 <a:cs typeface="Google Sans" pitchFamily="34" charset="-120"/>
               </a:rPr>
-              <a:t> to open it.</a:t>
+              <a:t> in your browser.</a:t>
             </a:r>
             <a:endParaRPr lang="en-US" sz="1200" dirty="0"/>
           </a:p>
@@ -15957,7 +15957,7 @@
         </p:nvSpPr>
         <p:spPr>
           <a:xfrm>
-            <a:off x="812788" y="711150"/>
+            <a:off x="812788" y="1488390"/>
             <a:ext cx="10883417" cy="292050"/>
           </a:xfrm>
           <a:prstGeom prst="rect">
@@ -16003,7 +16003,7 @@
         </p:nvSpPr>
         <p:spPr>
           <a:xfrm>
-            <a:off x="812788" y="1206376"/>
+            <a:off x="812788" y="1983616"/>
             <a:ext cx="9509760" cy="612093"/>
           </a:xfrm>
           <a:prstGeom prst="rect">
@@ -16045,8 +16045,8 @@
         </p:nvSpPr>
         <p:spPr>
           <a:xfrm>
-            <a:off x="812788" y="2021644"/>
-            <a:ext cx="4559287" cy="1112490"/>
+            <a:off x="813816" y="3566160"/>
+            <a:ext cx="3017520" cy="1143000"/>
           </a:xfrm>
           <a:prstGeom prst="roundRect">
             <a:avLst>
@@ -16074,8 +16074,8 @@
         </p:nvSpPr>
         <p:spPr>
           <a:xfrm>
-            <a:off x="1015938" y="2199432"/>
-            <a:ext cx="4277576" cy="253975"/>
+            <a:off x="1014984" y="3749040"/>
+            <a:ext cx="2651760" cy="274320"/>
           </a:xfrm>
           <a:prstGeom prst="rect">
             <a:avLst/>
@@ -16116,8 +16116,8 @@
         </p:nvSpPr>
         <p:spPr>
           <a:xfrm>
-            <a:off x="1015938" y="2478794"/>
-            <a:ext cx="4277576" cy="238782"/>
+            <a:off x="1014984" y="4041648"/>
+            <a:ext cx="2651760" cy="256032"/>
           </a:xfrm>
           <a:prstGeom prst="rect">
             <a:avLst/>
@@ -16158,8 +16158,8 @@
         </p:nvSpPr>
         <p:spPr>
           <a:xfrm>
-            <a:off x="1015938" y="2742964"/>
-            <a:ext cx="4277576" cy="238782"/>
+            <a:off x="1014984" y="4315968"/>
+            <a:ext cx="2651760" cy="256032"/>
           </a:xfrm>
           <a:prstGeom prst="rect">
             <a:avLst/>
@@ -16207,8 +16207,8 @@
         </p:nvSpPr>
         <p:spPr>
           <a:xfrm>
-            <a:off x="5524438" y="2021644"/>
-            <a:ext cx="4559349" cy="1112490"/>
+            <a:off x="4014216" y="3566160"/>
+            <a:ext cx="3017520" cy="1143000"/>
           </a:xfrm>
           <a:prstGeom prst="roundRect">
             <a:avLst>
@@ -16236,8 +16236,8 @@
         </p:nvSpPr>
         <p:spPr>
           <a:xfrm>
-            <a:off x="5727588" y="2199432"/>
-            <a:ext cx="4277640" cy="253975"/>
+            <a:off x="4215384" y="3749040"/>
+            <a:ext cx="2651760" cy="274320"/>
           </a:xfrm>
           <a:prstGeom prst="rect">
             <a:avLst/>
@@ -16278,8 +16278,8 @@
         </p:nvSpPr>
         <p:spPr>
           <a:xfrm>
-            <a:off x="5727588" y="2478794"/>
-            <a:ext cx="4277640" cy="238782"/>
+            <a:off x="4215384" y="4041648"/>
+            <a:ext cx="2651760" cy="256032"/>
           </a:xfrm>
           <a:prstGeom prst="rect">
             <a:avLst/>
@@ -16320,8 +16320,8 @@
         </p:nvSpPr>
         <p:spPr>
           <a:xfrm>
-            <a:off x="5727588" y="2742964"/>
-            <a:ext cx="4277640" cy="238782"/>
+            <a:off x="4215384" y="4315968"/>
+            <a:ext cx="2651760" cy="256032"/>
           </a:xfrm>
           <a:prstGeom prst="rect">
             <a:avLst/>
@@ -16369,8 +16369,8 @@
         </p:nvSpPr>
         <p:spPr>
           <a:xfrm>
-            <a:off x="3167368" y="3286497"/>
-            <a:ext cx="4559287" cy="1112490"/>
+            <a:off x="7214616" y="3566160"/>
+            <a:ext cx="3017520" cy="1143000"/>
           </a:xfrm>
           <a:prstGeom prst="roundRect">
             <a:avLst>
@@ -16398,8 +16398,8 @@
         </p:nvSpPr>
         <p:spPr>
           <a:xfrm>
-            <a:off x="3370518" y="3464285"/>
-            <a:ext cx="4277576" cy="253975"/>
+            <a:off x="7415784" y="3749040"/>
+            <a:ext cx="2651760" cy="274320"/>
           </a:xfrm>
           <a:prstGeom prst="rect">
             <a:avLst/>
@@ -16440,8 +16440,8 @@
         </p:nvSpPr>
         <p:spPr>
           <a:xfrm>
-            <a:off x="3370518" y="3743647"/>
-            <a:ext cx="4277576" cy="238782"/>
+            <a:off x="7415784" y="4041648"/>
+            <a:ext cx="2651760" cy="256032"/>
           </a:xfrm>
           <a:prstGeom prst="rect">
             <a:avLst/>
@@ -16482,8 +16482,8 @@
         </p:nvSpPr>
         <p:spPr>
           <a:xfrm>
-            <a:off x="3370518" y="4007817"/>
-            <a:ext cx="4277576" cy="238782"/>
+            <a:off x="7415784" y="4315968"/>
+            <a:ext cx="2651760" cy="256032"/>
           </a:xfrm>
           <a:prstGeom prst="rect">
             <a:avLst/>
@@ -16531,8 +16531,8 @@
         </p:nvSpPr>
         <p:spPr>
           <a:xfrm>
-            <a:off x="812788" y="4627563"/>
-            <a:ext cx="10883417" cy="256456"/>
+            <a:off x="813816" y="4983480"/>
+            <a:ext cx="9509760" cy="274320"/>
           </a:xfrm>
           <a:prstGeom prst="rect">
             <a:avLst/>
@@ -16559,9 +16559,51 @@
                 <a:ea typeface="Google Sans" pitchFamily="34" charset="-122"/>
                 <a:cs typeface="Google Sans" pitchFamily="34" charset="-120"/>
               </a:rPr>
-              <a:t>Any doubt in any step? Contact the technical team above, tap a link to open WhatsApp.</a:t>
+              <a:t>Tap Message on WhatsApp to open a chat with them directly.</a:t>
             </a:r>
             <a:endParaRPr lang="en-US" sz="1300" dirty="0"/>
+          </a:p>
+        </p:txBody>
+      </p:sp>
+      <p:sp>
+        <p:nvSpPr>
+          <p:cNvPr id="120" name="Help line"/>
+          <p:cNvSpPr/>
+          <p:nvPr/>
+        </p:nvSpPr>
+        <p:spPr>
+          <a:xfrm>
+            <a:off x="813816" y="2926080"/>
+            <a:ext cx="9509760" cy="411480"/>
+          </a:xfrm>
+          <a:prstGeom prst="rect">
+            <a:avLst/>
+          </a:prstGeom>
+          <a:noFill/>
+          <a:ln/>
+        </p:spPr>
+        <p:txBody>
+          <a:bodyPr wrap="square" lIns="0" tIns="0" rIns="0" bIns="0" rtlCol="0" anchor="t"/>
+          <a:lstStyle/>
+          <a:p>
+            <a:pPr marL="0" indent="0" algn="l">
+              <a:lnSpc>
+                <a:spcPts val="1820"/>
+              </a:lnSpc>
+              <a:buNone/>
+            </a:pPr>
+            <a:r>
+              <a:rPr b="1" lang="en-US" sz="2000" dirty="0">
+                <a:solidFill>
+                  <a:srgbClr val="E8F0FE"/>
+                </a:solidFill>
+                <a:latin typeface="Google Sans" pitchFamily="34" charset="0"/>
+                <a:ea typeface="Google Sans" pitchFamily="34" charset="-122"/>
+                <a:cs typeface="Google Sans" pitchFamily="34" charset="-120"/>
+              </a:rPr>
+              <a:t>Have any doubts in any step? Contact these people:</a:t>
+            </a:r>
+            <a:endParaRPr lang="en-US" sz="2000" dirty="0"/>
           </a:p>
         </p:txBody>
       </p:sp>

</xml_diff>

<commit_message>
Make GDGC-APSIT referral code bold red on step 11
Co-Authored-By: Claude Opus 5.5 <noreply@anthropic.com>
Claude-Session: https://claude.ai/code/session_01PKtiSCsUmxij3S1QgC1bpy
</commit_message>
<xml_diff>
--- a/Skill_Boost_Registration_Guide.pptx
+++ b/Skill_Boost_Registration_Guide.pptx
@@ -9544,7 +9544,18 @@
                 <a:ea typeface="Google Sans" pitchFamily="34" charset="-122"/>
                 <a:cs typeface="Google Sans" pitchFamily="34" charset="-120"/>
               </a:rPr>
-              <a:t>Type GDGC-APSIT</a:t>
+              <a:t xml:space="preserve">Type </a:t>
+            </a:r>
+            <a:r>
+              <a:rPr lang="en-US" sz="1600" b="1" dirty="0">
+                <a:solidFill>
+                  <a:srgbClr val="D93025"/>
+                </a:solidFill>
+                <a:latin typeface="Google Sans" pitchFamily="34" charset="0"/>
+                <a:ea typeface="Google Sans" pitchFamily="34" charset="-122"/>
+                <a:cs typeface="Google Sans" pitchFamily="34" charset="-120"/>
+              </a:rPr>
+              <a:t>GDGC-APSIT</a:t>
             </a:r>
             <a:endParaRPr lang="en-US" sz="1600" dirty="0"/>
           </a:p>
@@ -9586,7 +9597,29 @@
                 <a:ea typeface="Google Sans" pitchFamily="34" charset="-122"/>
                 <a:cs typeface="Google Sans" pitchFamily="34" charset="-120"/>
               </a:rPr>
-              <a:t>Type it exactly, in capitals with the hyphen, or you will not be credited to APSIT.</a:t>
+              <a:t xml:space="preserve">Type </a:t>
+            </a:r>
+            <a:r>
+              <a:rPr b="1" lang="en-US" sz="1200" dirty="0">
+                <a:solidFill>
+                  <a:srgbClr val="D93025"/>
+                </a:solidFill>
+                <a:latin typeface="Google Sans" pitchFamily="34" charset="0"/>
+                <a:ea typeface="Google Sans" pitchFamily="34" charset="-122"/>
+                <a:cs typeface="Google Sans" pitchFamily="34" charset="-120"/>
+              </a:rPr>
+              <a:t>GDGC-APSIT</a:t>
+            </a:r>
+            <a:r>
+              <a:rPr lang="en-US" sz="1200" dirty="0">
+                <a:solidFill>
+                  <a:srgbClr val="3C4043"/>
+                </a:solidFill>
+                <a:latin typeface="Google Sans" pitchFamily="34" charset="0"/>
+                <a:ea typeface="Google Sans" pitchFamily="34" charset="-122"/>
+                <a:cs typeface="Google Sans" pitchFamily="34" charset="-120"/>
+              </a:rPr>
+              <a:t xml:space="preserve"> exactly, in capitals with the hyphen, or you will not be credited.</a:t>
             </a:r>
             <a:endParaRPr lang="en-US" sz="1200" dirty="0"/>
           </a:p>

</xml_diff>